<commit_message>
UI / Implement stock location
</commit_message>
<xml_diff>
--- a/5-Implementation-Projects/internet/jagports/solution/vieps/UI_CONCEPTS/VIEPS UI-Concepts.pptx
+++ b/5-Implementation-Projects/internet/jagports/solution/vieps/UI_CONCEPTS/VIEPS UI-Concepts.pptx
@@ -130,7 +130,7 @@
   <pc:docChgLst>
     <pc:chgData name="Tomi Lind" userId="8de46aee-b41d-491b-a3c8-daf1b5776a2e" providerId="ADAL" clId="{DA4176E6-4A74-4541-B8FC-EC14009AAF7D}"/>
     <pc:docChg chg="undo redo custSel addSld modSld sldOrd">
-      <pc:chgData name="Tomi Lind" userId="8de46aee-b41d-491b-a3c8-daf1b5776a2e" providerId="ADAL" clId="{DA4176E6-4A74-4541-B8FC-EC14009AAF7D}" dt="2026-09-22T11:45:00.208" v="2016" actId="1076"/>
+      <pc:chgData name="Tomi Lind" userId="8de46aee-b41d-491b-a3c8-daf1b5776a2e" providerId="ADAL" clId="{DA4176E6-4A74-4541-B8FC-EC14009AAF7D}" dt="2026-09-22T12:16:19.817" v="2167" actId="6549"/>
       <pc:docMkLst>
         <pc:docMk/>
       </pc:docMkLst>
@@ -643,7 +643,7 @@
         </pc:picChg>
       </pc:sldChg>
       <pc:sldChg chg="addSp delSp modSp add mod">
-        <pc:chgData name="Tomi Lind" userId="8de46aee-b41d-491b-a3c8-daf1b5776a2e" providerId="ADAL" clId="{DA4176E6-4A74-4541-B8FC-EC14009AAF7D}" dt="2026-09-22T11:45:00.208" v="2016" actId="1076"/>
+        <pc:chgData name="Tomi Lind" userId="8de46aee-b41d-491b-a3c8-daf1b5776a2e" providerId="ADAL" clId="{DA4176E6-4A74-4541-B8FC-EC14009AAF7D}" dt="2026-09-22T12:16:19.817" v="2167" actId="6549"/>
         <pc:sldMkLst>
           <pc:docMk/>
           <pc:sldMk cId="2519818258" sldId="260"/>
@@ -801,7 +801,7 @@
           </ac:spMkLst>
         </pc:spChg>
         <pc:spChg chg="mod">
-          <ac:chgData name="Tomi Lind" userId="8de46aee-b41d-491b-a3c8-daf1b5776a2e" providerId="ADAL" clId="{DA4176E6-4A74-4541-B8FC-EC14009AAF7D}" dt="2026-09-22T11:34:44.593" v="1884" actId="1076"/>
+          <ac:chgData name="Tomi Lind" userId="8de46aee-b41d-491b-a3c8-daf1b5776a2e" providerId="ADAL" clId="{DA4176E6-4A74-4541-B8FC-EC14009AAF7D}" dt="2026-09-22T12:14:34.885" v="2018" actId="14100"/>
           <ac:spMkLst>
             <pc:docMk/>
             <pc:sldMk cId="2519818258" sldId="260"/>
@@ -809,7 +809,7 @@
           </ac:spMkLst>
         </pc:spChg>
         <pc:spChg chg="add mod">
-          <ac:chgData name="Tomi Lind" userId="8de46aee-b41d-491b-a3c8-daf1b5776a2e" providerId="ADAL" clId="{DA4176E6-4A74-4541-B8FC-EC14009AAF7D}" dt="2026-09-22T11:42:20.453" v="1999" actId="14100"/>
+          <ac:chgData name="Tomi Lind" userId="8de46aee-b41d-491b-a3c8-daf1b5776a2e" providerId="ADAL" clId="{DA4176E6-4A74-4541-B8FC-EC14009AAF7D}" dt="2026-09-22T12:14:31.295" v="2017" actId="14100"/>
           <ac:spMkLst>
             <pc:docMk/>
             <pc:sldMk cId="2519818258" sldId="260"/>
@@ -944,6 +944,14 @@
             <ac:spMk id="69" creationId="{F6696454-F025-0AB6-AC03-7B58000E68C4}"/>
           </ac:spMkLst>
         </pc:spChg>
+        <pc:spChg chg="add mod">
+          <ac:chgData name="Tomi Lind" userId="8de46aee-b41d-491b-a3c8-daf1b5776a2e" providerId="ADAL" clId="{DA4176E6-4A74-4541-B8FC-EC14009AAF7D}" dt="2026-09-22T12:16:19.817" v="2167" actId="6549"/>
+          <ac:spMkLst>
+            <pc:docMk/>
+            <pc:sldMk cId="2519818258" sldId="260"/>
+            <ac:spMk id="71" creationId="{8F1FB1CB-DD17-8ED4-3B4D-3804DD84C8D6}"/>
+          </ac:spMkLst>
+        </pc:spChg>
         <pc:grpChg chg="mod">
           <ac:chgData name="Tomi Lind" userId="8de46aee-b41d-491b-a3c8-daf1b5776a2e" providerId="ADAL" clId="{DA4176E6-4A74-4541-B8FC-EC14009AAF7D}" dt="2026-09-22T11:43:17.410" v="2011" actId="1076"/>
           <ac:grpSpMkLst>
@@ -969,7 +977,7 @@
           </ac:picMkLst>
         </pc:picChg>
         <pc:picChg chg="mod">
-          <ac:chgData name="Tomi Lind" userId="8de46aee-b41d-491b-a3c8-daf1b5776a2e" providerId="ADAL" clId="{DA4176E6-4A74-4541-B8FC-EC14009AAF7D}" dt="2026-09-22T11:34:44.593" v="1884" actId="1076"/>
+          <ac:chgData name="Tomi Lind" userId="8de46aee-b41d-491b-a3c8-daf1b5776a2e" providerId="ADAL" clId="{DA4176E6-4A74-4541-B8FC-EC14009AAF7D}" dt="2026-09-22T12:14:40.683" v="2020" actId="1076"/>
           <ac:picMkLst>
             <pc:docMk/>
             <pc:sldMk cId="2519818258" sldId="260"/>
@@ -977,7 +985,7 @@
           </ac:picMkLst>
         </pc:picChg>
         <pc:picChg chg="mod">
-          <ac:chgData name="Tomi Lind" userId="8de46aee-b41d-491b-a3c8-daf1b5776a2e" providerId="ADAL" clId="{DA4176E6-4A74-4541-B8FC-EC14009AAF7D}" dt="2026-09-22T11:34:44.593" v="1884" actId="1076"/>
+          <ac:chgData name="Tomi Lind" userId="8de46aee-b41d-491b-a3c8-daf1b5776a2e" providerId="ADAL" clId="{DA4176E6-4A74-4541-B8FC-EC14009AAF7D}" dt="2026-09-22T12:14:38.274" v="2019" actId="1076"/>
           <ac:picMkLst>
             <pc:docMk/>
             <pc:sldMk cId="2519818258" sldId="260"/>
@@ -4499,7 +4507,7 @@
         </p:blipFill>
         <p:spPr>
           <a:xfrm>
-            <a:off x="2549636" y="2884609"/>
+            <a:off x="2549636" y="3250647"/>
             <a:ext cx="2698044" cy="745067"/>
           </a:xfrm>
           <a:prstGeom prst="rect">
@@ -4535,7 +4543,7 @@
         </p:blipFill>
         <p:spPr>
           <a:xfrm>
-            <a:off x="2556091" y="3701666"/>
+            <a:off x="2549636" y="4460018"/>
             <a:ext cx="2705100" cy="1057275"/>
           </a:xfrm>
           <a:prstGeom prst="rect">
@@ -5745,8 +5753,8 @@
         </p:nvSpPr>
         <p:spPr>
           <a:xfrm>
-            <a:off x="2341947" y="2553336"/>
-            <a:ext cx="3193992" cy="2333922"/>
+            <a:off x="2341947" y="2553335"/>
+            <a:ext cx="3193992" cy="3794301"/>
           </a:xfrm>
           <a:prstGeom prst="roundRect">
             <a:avLst/>
@@ -5887,7 +5895,7 @@
         <p:spPr>
           <a:xfrm>
             <a:off x="5634758" y="2553059"/>
-            <a:ext cx="4662639" cy="2333922"/>
+            <a:ext cx="4662639" cy="3794578"/>
           </a:xfrm>
           <a:prstGeom prst="roundRect">
             <a:avLst/>
@@ -7428,6 +7436,182 @@
               <a:t>BANNER</a:t>
             </a:r>
             <a:endParaRPr lang="LID4096" dirty="0"/>
+          </a:p>
+        </p:txBody>
+      </p:sp>
+      <p:sp>
+        <p:nvSpPr>
+          <p:cNvPr id="71" name="TextBox 13">
+            <a:extLst>
+              <a:ext uri="{FF2B5EF4-FFF2-40B4-BE49-F238E27FC236}">
+                <a16:creationId xmlns:a16="http://schemas.microsoft.com/office/drawing/2014/main" id="{8F1FB1CB-DD17-8ED4-3B4D-3804DD84C8D6}"/>
+              </a:ext>
+            </a:extLst>
+          </p:cNvPr>
+          <p:cNvSpPr txBox="1"/>
+          <p:nvPr/>
+        </p:nvSpPr>
+        <p:spPr>
+          <a:xfrm>
+            <a:off x="4803218" y="5117788"/>
+            <a:ext cx="6288802" cy="400110"/>
+          </a:xfrm>
+          <a:prstGeom prst="rect">
+            <a:avLst/>
+          </a:prstGeom>
+          <a:noFill/>
+        </p:spPr>
+        <p:txBody>
+          <a:bodyPr wrap="square">
+            <a:spAutoFit/>
+          </a:bodyPr>
+          <a:lstStyle>
+            <a:defPPr>
+              <a:defRPr lang="LID4096"/>
+            </a:defPPr>
+            <a:lvl1pPr marL="0" algn="l" defTabSz="914400" rtl="0" eaLnBrk="1" latinLnBrk="0" hangingPunct="1">
+              <a:defRPr sz="1800" kern="1200">
+                <a:solidFill>
+                  <a:schemeClr val="tx1"/>
+                </a:solidFill>
+                <a:latin typeface="+mn-lt"/>
+                <a:ea typeface="+mn-ea"/>
+                <a:cs typeface="+mn-cs"/>
+              </a:defRPr>
+            </a:lvl1pPr>
+            <a:lvl2pPr marL="457200" algn="l" defTabSz="914400" rtl="0" eaLnBrk="1" latinLnBrk="0" hangingPunct="1">
+              <a:defRPr sz="1800" kern="1200">
+                <a:solidFill>
+                  <a:schemeClr val="tx1"/>
+                </a:solidFill>
+                <a:latin typeface="+mn-lt"/>
+                <a:ea typeface="+mn-ea"/>
+                <a:cs typeface="+mn-cs"/>
+              </a:defRPr>
+            </a:lvl2pPr>
+            <a:lvl3pPr marL="914400" algn="l" defTabSz="914400" rtl="0" eaLnBrk="1" latinLnBrk="0" hangingPunct="1">
+              <a:defRPr sz="1800" kern="1200">
+                <a:solidFill>
+                  <a:schemeClr val="tx1"/>
+                </a:solidFill>
+                <a:latin typeface="+mn-lt"/>
+                <a:ea typeface="+mn-ea"/>
+                <a:cs typeface="+mn-cs"/>
+              </a:defRPr>
+            </a:lvl3pPr>
+            <a:lvl4pPr marL="1371600" algn="l" defTabSz="914400" rtl="0" eaLnBrk="1" latinLnBrk="0" hangingPunct="1">
+              <a:defRPr sz="1800" kern="1200">
+                <a:solidFill>
+                  <a:schemeClr val="tx1"/>
+                </a:solidFill>
+                <a:latin typeface="+mn-lt"/>
+                <a:ea typeface="+mn-ea"/>
+                <a:cs typeface="+mn-cs"/>
+              </a:defRPr>
+            </a:lvl4pPr>
+            <a:lvl5pPr marL="1828800" algn="l" defTabSz="914400" rtl="0" eaLnBrk="1" latinLnBrk="0" hangingPunct="1">
+              <a:defRPr sz="1800" kern="1200">
+                <a:solidFill>
+                  <a:schemeClr val="tx1"/>
+                </a:solidFill>
+                <a:latin typeface="+mn-lt"/>
+                <a:ea typeface="+mn-ea"/>
+                <a:cs typeface="+mn-cs"/>
+              </a:defRPr>
+            </a:lvl5pPr>
+            <a:lvl6pPr marL="2286000" algn="l" defTabSz="914400" rtl="0" eaLnBrk="1" latinLnBrk="0" hangingPunct="1">
+              <a:defRPr sz="1800" kern="1200">
+                <a:solidFill>
+                  <a:schemeClr val="tx1"/>
+                </a:solidFill>
+                <a:latin typeface="+mn-lt"/>
+                <a:ea typeface="+mn-ea"/>
+                <a:cs typeface="+mn-cs"/>
+              </a:defRPr>
+            </a:lvl6pPr>
+            <a:lvl7pPr marL="2743200" algn="l" defTabSz="914400" rtl="0" eaLnBrk="1" latinLnBrk="0" hangingPunct="1">
+              <a:defRPr sz="1800" kern="1200">
+                <a:solidFill>
+                  <a:schemeClr val="tx1"/>
+                </a:solidFill>
+                <a:latin typeface="+mn-lt"/>
+                <a:ea typeface="+mn-ea"/>
+                <a:cs typeface="+mn-cs"/>
+              </a:defRPr>
+            </a:lvl7pPr>
+            <a:lvl8pPr marL="3200400" algn="l" defTabSz="914400" rtl="0" eaLnBrk="1" latinLnBrk="0" hangingPunct="1">
+              <a:defRPr sz="1800" kern="1200">
+                <a:solidFill>
+                  <a:schemeClr val="tx1"/>
+                </a:solidFill>
+                <a:latin typeface="+mn-lt"/>
+                <a:ea typeface="+mn-ea"/>
+                <a:cs typeface="+mn-cs"/>
+              </a:defRPr>
+            </a:lvl8pPr>
+            <a:lvl9pPr marL="3657600" algn="l" defTabSz="914400" rtl="0" eaLnBrk="1" latinLnBrk="0" hangingPunct="1">
+              <a:defRPr sz="1800" kern="1200">
+                <a:solidFill>
+                  <a:schemeClr val="tx1"/>
+                </a:solidFill>
+                <a:latin typeface="+mn-lt"/>
+                <a:ea typeface="+mn-ea"/>
+                <a:cs typeface="+mn-cs"/>
+              </a:defRPr>
+            </a:lvl9pPr>
+          </a:lstStyle>
+          <a:p>
+            <a:pPr algn="ctr"/>
+            <a:r>
+              <a:rPr lang="en-GB" sz="1000" dirty="0" err="1">
+                <a:solidFill>
+                  <a:schemeClr val="tx2">
+                    <a:lumMod val="50000"/>
+                    <a:lumOff val="50000"/>
+                  </a:schemeClr>
+                </a:solidFill>
+              </a:rPr>
+              <a:t>Aveilable</a:t>
+            </a:r>
+            <a:r>
+              <a:rPr lang="en-GB" sz="1000" dirty="0">
+                <a:solidFill>
+                  <a:schemeClr val="tx2">
+                    <a:lumMod val="50000"/>
+                    <a:lumOff val="50000"/>
+                  </a:schemeClr>
+                </a:solidFill>
+              </a:rPr>
+              <a:t> at: [Stock Location – Site name(s) – if available]</a:t>
+            </a:r>
+            <a:endParaRPr lang="en-US" sz="1000" dirty="0">
+              <a:solidFill>
+                <a:schemeClr val="tx2">
+                  <a:lumMod val="50000"/>
+                  <a:lumOff val="50000"/>
+                </a:schemeClr>
+              </a:solidFill>
+            </a:endParaRPr>
+          </a:p>
+          <a:p>
+            <a:pPr algn="ctr"/>
+            <a:r>
+              <a:rPr lang="en-US" sz="1000"/>
+              <a:t>Detailed </a:t>
+            </a:r>
+            <a:r>
+              <a:rPr lang="en-US" sz="1000" dirty="0"/>
+              <a:t>location on stock – </a:t>
+            </a:r>
+            <a:r>
+              <a:rPr lang="en-US" sz="1000" dirty="0" err="1"/>
+              <a:t>PostMVP</a:t>
+            </a:r>
+            <a:r>
+              <a:rPr lang="en-US" sz="1000" dirty="0"/>
+              <a:t> visible only to admins</a:t>
+            </a:r>
+            <a:endParaRPr lang="" sz="1000" dirty="0"/>
           </a:p>
         </p:txBody>
       </p:sp>

</xml_diff>